<commit_message>
Plate suppliers aligned with the plate specification
Appendix A and the suppliers slide now offer only the two materials of section 1d
(finish-ground aluminum tooling plate or float glass); the granite option is dropped.
Both say that the supplier's flatness report is the starting document and that the
0.05 mm is confirmed in-house after painting and mounting.

Co-Authored-By: Claude Fable 5.1 <noreply@anthropic.com>
Claude-Session: https://claude.ai/code/session_016X9U4SzM2dXD3fEs3wV3Mm
</commit_message>
<xml_diff>
--- a/docs/presentations/registration_procurement_build.pptx
+++ b/docs/presentations/registration_procurement_build.pptx
@@ -116,27 +116,27 @@
   <p:extLst>
     <p:ext uri="{521415D9-36F7-43E2-AB2F-B90AF26B5E84}">
       <p14:sectionLst xmlns:p14="http://schemas.microsoft.com/office/powerpoint/2010/main">
-        <p14:section name="Introduction" id="{3331942e-c55d-27f2-1971-ad0437e71a19}">
+        <p14:section name="Introduction" id="{bf14626d-dd6f-a3d7-3c15-e6a4aa658351}">
           <p14:sldIdLst>
             <p14:sldId id="256"/>
             <p14:sldId id="257"/>
           </p14:sldIdLst>
         </p14:section>
-        <p14:section name="Scope of work" id="{e186e3c2-46b7-fd2f-f516-3fc57ce86b21}">
+        <p14:section name="Scope of work" id="{596617af-f6d9-5ba1-0115-234edc316cdd}">
           <p14:sldIdLst>
             <p14:sldId id="258"/>
             <p14:sldId id="259"/>
             <p14:sldId id="260"/>
           </p14:sldIdLst>
         </p14:section>
-        <p14:section name="Procurement" id="{0d594dd5-8ec8-f46a-da4e-eb7627f3c6cc}">
+        <p14:section name="Procurement" id="{4a66c495-c596-7e38-e37a-cae058354751}">
           <p14:sldIdLst>
             <p14:sldId id="261"/>
             <p14:sldId id="262"/>
             <p14:sldId id="263"/>
           </p14:sldIdLst>
         </p14:section>
-        <p14:section name="Mechanical build" id="{59540bb3-903b-059c-926a-14161e35255a}">
+        <p14:section name="Mechanical build" id="{53ff8779-e253-5ada-6cb5-e940059653fb}">
           <p14:sldIdLst>
             <p14:sldId id="264"/>
             <p14:sldId id="265"/>
@@ -1162,7 +1162,7 @@
           <a:p>
             <a:r>
               <a:rPr lang="en-US" dirty="0"/>
-              <a:t>This is appendix A of the procedure in brief, the stage-1 supplier list reduced to the items this procedure uses. MIC-6 tooling plate is sold with a stated flatness of about 0.13 mm, coarser than the 0.05 mm asked for, so the plate is ordered oversize and finish-ground by a local shop; float glass is flat enough as delivered and is the better choice where no grinding shop is at hand; a small granite surface plate works if its front is painted and the robot carries the weight. The instruments are stock items. The adapter is a one-off job for a machine shop, built to drawing SC1-05.</a:t>
+              <a:t>This is appendix A of the procedure in brief, the stage-1 supplier list reduced to the items this procedure uses. The plate is one of the two materials of the specification on the previous slide: MIC-6 tooling plate is sold with a stated flatness of about 0.13 mm, coarser than the 0.05 mm asked for, so it is ordered oversize and finish-ground by a local shop; float glass is flat enough as delivered and is the better choice where no grinding shop is at hand. In both cases the supplier's or grinding shop's flatness report is the starting document, and the 0.05 mm is confirmed in-house with the straightedge and feeler leaf after painting and after mounting, the state the sensor sees. The instruments are stock items. The adapter is a one-off job for a machine shop, built to drawing SC1-05.</a:t>
             </a:r>
             <a:endParaRPr lang="en-US" dirty="0"/>
           </a:p>
@@ -9241,7 +9241,7 @@
                             <a:schemeClr val="tx1"/>
                           </a:solidFill>
                         </a:rPr>
-                        <a:t>McMaster-Carr MIC-6 plus a grinding shop; Edmund Optics float glass; a small granite surface plate</a:t>
+                        <a:t>McMaster-Carr MIC-6 plus a grinding shop; Edmund Optics float glass</a:t>
                       </a:r>
                       <a:endParaRPr lang="en-US" sz="1400" dirty="0"/>
                     </a:p>
@@ -9302,7 +9302,7 @@
                             <a:schemeClr val="tx1"/>
                           </a:solidFill>
                         </a:rPr>
-                        <a:t>Painted matte after grinding; flatness checked after mounting</a:t>
+                        <a:t>Ground or glass to 0.05 mm with a flatness report; painted matte; re-checked in-house after painting and mounting</a:t>
                       </a:r>
                       <a:endParaRPr lang="en-US" sz="1400" dirty="0"/>
                     </a:p>

</xml_diff>

<commit_message>
Procedure and decks: the remount check
Section 3 gains a remount check: after any remount, repeat the run-out and D
measurements (0.05 mm), re-capture the saved reference pose boot01 as boot01r and
compare the bootstrap's before-and-after residual rows (0.2 degrees, 0.2 mm,
placeholders), and record the remount; sections 4, 6, 9 and 10 hook into it. Both
decks carry it (acceptance checklist; board slide; spoilers). Decision 17 logged.

Co-Authored-By: Claude Fable 5.1 <noreply@anthropic.com>
Claude-Session: https://claude.ai/code/session_016X9U4SzM2dXD3fEs3wV3Mm
</commit_message>
<xml_diff>
--- a/docs/presentations/registration_procurement_build.pptx
+++ b/docs/presentations/registration_procurement_build.pptx
@@ -116,27 +116,27 @@
   <p:extLst>
     <p:ext uri="{521415D9-36F7-43E2-AB2F-B90AF26B5E84}">
       <p14:sectionLst xmlns:p14="http://schemas.microsoft.com/office/powerpoint/2010/main">
-        <p14:section name="Introduction" id="{bf14626d-dd6f-a3d7-3c15-e6a4aa658351}">
+        <p14:section name="Introduction" id="{19c1be62-c1d5-59b0-918a-047569185b67}">
           <p14:sldIdLst>
             <p14:sldId id="256"/>
             <p14:sldId id="257"/>
           </p14:sldIdLst>
         </p14:section>
-        <p14:section name="Scope of work" id="{596617af-f6d9-5ba1-0115-234edc316cdd}">
+        <p14:section name="Scope of work" id="{e0a4f3b6-12b0-860a-278d-b1bbadd4801f}">
           <p14:sldIdLst>
             <p14:sldId id="258"/>
             <p14:sldId id="259"/>
             <p14:sldId id="260"/>
           </p14:sldIdLst>
         </p14:section>
-        <p14:section name="Procurement" id="{4a66c495-c596-7e38-e37a-cae058354751}">
+        <p14:section name="Procurement" id="{bd72de80-c9ee-2cf6-c1ff-c81026820a5b}">
           <p14:sldIdLst>
             <p14:sldId id="261"/>
             <p14:sldId id="262"/>
             <p14:sldId id="263"/>
           </p14:sldIdLst>
         </p14:section>
-        <p14:section name="Mechanical build" id="{53ff8779-e253-5ada-6cb5-e940059653fb}">
+        <p14:section name="Mechanical build" id="{399c4907-bb2e-c355-a4be-f35ce46c45c7}">
           <p14:sldIdLst>
             <p14:sldId id="264"/>
             <p14:sldId id="265"/>
@@ -634,7 +634,7 @@
           <a:p>
             <a:r>
               <a:rPr lang="en-US" dirty="0"/>
-              <a:t>These are the build and preparation checks of sections 1 and 3 of the procedure, gathered in one place. Each protects something the software cannot repair later: a board that is not flat gives plane residuals the registration reads as sensor error; a glossy spot returns a highlight and a bad read; a loose or unseated adapter shifts the board between poses and spoils every pose after it; wrong tool load data shifts every reported pose. The run-out and D measurements themselves are session steps, in deck 2.</a:t>
+              <a:t>These are the build and preparation checks of sections 1 and 3 of the procedure, gathered in one place. Each protects something the software cannot repair later: a board that is not flat gives plane residuals the registration reads as sensor error; a glossy spot returns a highlight and a bad read; a loose or unseated adapter shifts the board between poses and spoils every pose after it; wrong tool load data shifts every reported pose. The run-out and D measurements themselves are session steps, in deck 2. A remount is verified, not assumed: section 3 of the procedure repeats the run-out check and the D measurement and re-captures a saved reference pose, so that any change of the board's plane relative to the flange shows before it spoils a run.</a:t>
             </a:r>
             <a:endParaRPr lang="en-US" dirty="0"/>
           </a:p>
@@ -2785,7 +2785,7 @@
                   <a:schemeClr val="tx1"/>
                 </a:solidFill>
               </a:rPr>
-              <a:t>Dowels seated; the board goes back in the same place after a remount</a:t>
+              <a:t>Dowels seated; after any remount, the remount check of the procedure (run-out, D, reference capture) passes</a:t>
             </a:r>
             <a:endParaRPr lang="en-US" sz="1600" dirty="0"/>
           </a:p>

</xml_diff>